<commit_message>
Making changes to the first two slides.
</commit_message>
<xml_diff>
--- a/steganographySlides.pptx
+++ b/steganographySlides.pptx
@@ -7,7 +7,7 @@
   <p:sldIdLst>
     <p:sldId id="256" r:id="rId2"/>
     <p:sldId id="259" r:id="rId3"/>
-    <p:sldId id="260" r:id="rId4"/>
+    <p:sldId id="263" r:id="rId4"/>
     <p:sldId id="261" r:id="rId5"/>
     <p:sldId id="262" r:id="rId6"/>
   </p:sldIdLst>
@@ -284,7 +284,7 @@
           <a:p>
             <a:fld id="{BB668030-A114-4385-8D34-D6535427301A}" type="datetimeFigureOut">
               <a:rPr lang="en-US" smtClean="0"/>
-              <a:t>6/18/2026</a:t>
+              <a:t>6/19/2026</a:t>
             </a:fld>
             <a:endParaRPr lang="en-US"/>
           </a:p>
@@ -519,7 +519,7 @@
           <a:p>
             <a:fld id="{BB668030-A114-4385-8D34-D6535427301A}" type="datetimeFigureOut">
               <a:rPr lang="en-US" smtClean="0"/>
-              <a:t>6/18/2026</a:t>
+              <a:t>6/19/2026</a:t>
             </a:fld>
             <a:endParaRPr lang="en-US"/>
           </a:p>
@@ -699,7 +699,7 @@
           <a:p>
             <a:fld id="{BB668030-A114-4385-8D34-D6535427301A}" type="datetimeFigureOut">
               <a:rPr lang="en-US" smtClean="0"/>
-              <a:t>6/18/2026</a:t>
+              <a:t>6/19/2026</a:t>
             </a:fld>
             <a:endParaRPr lang="en-US"/>
           </a:p>
@@ -869,7 +869,7 @@
           <a:p>
             <a:fld id="{BB668030-A114-4385-8D34-D6535427301A}" type="datetimeFigureOut">
               <a:rPr lang="en-US" smtClean="0"/>
-              <a:t>6/18/2026</a:t>
+              <a:t>6/19/2026</a:t>
             </a:fld>
             <a:endParaRPr lang="en-US"/>
           </a:p>
@@ -1123,7 +1123,7 @@
           <a:p>
             <a:fld id="{BB668030-A114-4385-8D34-D6535427301A}" type="datetimeFigureOut">
               <a:rPr lang="en-US" smtClean="0"/>
-              <a:t>6/18/2026</a:t>
+              <a:t>6/19/2026</a:t>
             </a:fld>
             <a:endParaRPr lang="en-US"/>
           </a:p>
@@ -1449,7 +1449,7 @@
           <a:p>
             <a:fld id="{BB668030-A114-4385-8D34-D6535427301A}" type="datetimeFigureOut">
               <a:rPr lang="en-US" smtClean="0"/>
-              <a:t>6/18/2026</a:t>
+              <a:t>6/19/2026</a:t>
             </a:fld>
             <a:endParaRPr lang="en-US"/>
           </a:p>
@@ -1900,7 +1900,7 @@
           <a:p>
             <a:fld id="{BB668030-A114-4385-8D34-D6535427301A}" type="datetimeFigureOut">
               <a:rPr lang="en-US" smtClean="0"/>
-              <a:t>6/18/2026</a:t>
+              <a:t>6/19/2026</a:t>
             </a:fld>
             <a:endParaRPr lang="en-US"/>
           </a:p>
@@ -2018,7 +2018,7 @@
           <a:p>
             <a:fld id="{BB668030-A114-4385-8D34-D6535427301A}" type="datetimeFigureOut">
               <a:rPr lang="en-US" smtClean="0"/>
-              <a:t>6/18/2026</a:t>
+              <a:t>6/19/2026</a:t>
             </a:fld>
             <a:endParaRPr lang="en-US"/>
           </a:p>
@@ -2113,7 +2113,7 @@
           <a:p>
             <a:fld id="{BB668030-A114-4385-8D34-D6535427301A}" type="datetimeFigureOut">
               <a:rPr lang="en-US" smtClean="0"/>
-              <a:t>6/18/2026</a:t>
+              <a:t>6/19/2026</a:t>
             </a:fld>
             <a:endParaRPr lang="en-US"/>
           </a:p>
@@ -2400,7 +2400,7 @@
           <a:p>
             <a:fld id="{BB668030-A114-4385-8D34-D6535427301A}" type="datetimeFigureOut">
               <a:rPr lang="en-US" smtClean="0"/>
-              <a:t>6/18/2026</a:t>
+              <a:t>6/19/2026</a:t>
             </a:fld>
             <a:endParaRPr lang="en-US"/>
           </a:p>
@@ -2722,7 +2722,7 @@
           <a:p>
             <a:fld id="{BB668030-A114-4385-8D34-D6535427301A}" type="datetimeFigureOut">
               <a:rPr lang="en-US" smtClean="0"/>
-              <a:t>6/18/2026</a:t>
+              <a:t>6/19/2026</a:t>
             </a:fld>
             <a:endParaRPr lang="en-US"/>
           </a:p>
@@ -2983,7 +2983,7 @@
           <a:p>
             <a:fld id="{BB668030-A114-4385-8D34-D6535427301A}" type="datetimeFigureOut">
               <a:rPr lang="en-US" smtClean="0"/>
-              <a:t>6/18/2026</a:t>
+              <a:t>6/19/2026</a:t>
             </a:fld>
             <a:endParaRPr lang="en-US"/>
           </a:p>
@@ -3624,7 +3624,7 @@
         </p:nvSpPr>
         <p:spPr>
           <a:xfrm>
-            <a:off x="1249680" y="497633"/>
+            <a:off x="596326" y="324013"/>
             <a:ext cx="9692640" cy="714718"/>
           </a:xfrm>
         </p:spPr>
@@ -3633,7 +3633,10 @@
           <a:lstStyle/>
           <a:p>
             <a:r>
-              <a:rPr lang="en-US" dirty="0"/>
+              <a:rPr lang="en-US" dirty="0">
+                <a:latin typeface="Arial" panose="020B0604020202020204" pitchFamily="34" charset="0"/>
+                <a:cs typeface="Arial" panose="020B0604020202020204" pitchFamily="34" charset="0"/>
+              </a:rPr>
               <a:t>What is Steganography?</a:t>
             </a:r>
           </a:p>
@@ -3655,7 +3658,12 @@
             <p:ph idx="1"/>
           </p:nvPr>
         </p:nvSpPr>
-        <p:spPr/>
+        <p:spPr>
+          <a:xfrm>
+            <a:off x="596326" y="1574157"/>
+            <a:ext cx="10058169" cy="4351337"/>
+          </a:xfrm>
+        </p:spPr>
         <p:txBody>
           <a:bodyPr/>
           <a:lstStyle/>
@@ -3664,8 +3672,18 @@
               <a:buNone/>
             </a:pPr>
             <a:r>
-              <a:rPr lang="en-US" dirty="0"/>
-              <a:t>Steganography is the art and science of hiding secret information inside another file, such as:</a:t>
+              <a:rPr lang="en-US" sz="2000" b="1" dirty="0">
+                <a:latin typeface="Arial" panose="020B0604020202020204" pitchFamily="34" charset="0"/>
+                <a:cs typeface="Arial" panose="020B0604020202020204" pitchFamily="34" charset="0"/>
+              </a:rPr>
+              <a:t>Steganography</a:t>
+            </a:r>
+            <a:r>
+              <a:rPr lang="en-US" sz="2000" dirty="0">
+                <a:latin typeface="Arial" panose="020B0604020202020204" pitchFamily="34" charset="0"/>
+                <a:cs typeface="Arial" panose="020B0604020202020204" pitchFamily="34" charset="0"/>
+              </a:rPr>
+              <a:t> is the practice of hiding information inside another information object, such as:</a:t>
             </a:r>
           </a:p>
           <a:p>
@@ -3674,8 +3692,11 @@
               <a:buChar char="•"/>
             </a:pPr>
             <a:r>
-              <a:rPr lang="en-US" dirty="0"/>
-              <a:t>Images </a:t>
+              <a:rPr lang="en-US" sz="2000" dirty="0">
+                <a:latin typeface="Arial" panose="020B0604020202020204" pitchFamily="34" charset="0"/>
+                <a:cs typeface="Arial" panose="020B0604020202020204" pitchFamily="34" charset="0"/>
+              </a:rPr>
+              <a:t>Text inside an image</a:t>
             </a:r>
           </a:p>
           <a:p>
@@ -3684,8 +3705,11 @@
               <a:buChar char="•"/>
             </a:pPr>
             <a:r>
-              <a:rPr lang="en-US" dirty="0"/>
-              <a:t>Text files </a:t>
+              <a:rPr lang="en-US" sz="2000" dirty="0">
+                <a:latin typeface="Arial" panose="020B0604020202020204" pitchFamily="34" charset="0"/>
+                <a:cs typeface="Arial" panose="020B0604020202020204" pitchFamily="34" charset="0"/>
+              </a:rPr>
+              <a:t>Text inside another text</a:t>
             </a:r>
           </a:p>
           <a:p>
@@ -3694,8 +3718,11 @@
               <a:buChar char="•"/>
             </a:pPr>
             <a:r>
-              <a:rPr lang="en-US" dirty="0"/>
-              <a:t>Audio files </a:t>
+              <a:rPr lang="en-US" sz="2000" dirty="0">
+                <a:latin typeface="Arial" panose="020B0604020202020204" pitchFamily="34" charset="0"/>
+                <a:cs typeface="Arial" panose="020B0604020202020204" pitchFamily="34" charset="0"/>
+              </a:rPr>
+              <a:t>Audio inside video</a:t>
             </a:r>
           </a:p>
           <a:p>
@@ -3704,24 +3731,41 @@
               <a:buChar char="•"/>
             </a:pPr>
             <a:r>
-              <a:rPr lang="en-US" dirty="0"/>
-              <a:t>Video files </a:t>
+              <a:rPr lang="en-US" sz="2000" dirty="0">
+                <a:latin typeface="Arial" panose="020B0604020202020204" pitchFamily="34" charset="0"/>
+                <a:cs typeface="Arial" panose="020B0604020202020204" pitchFamily="34" charset="0"/>
+              </a:rPr>
+              <a:t>Image inside another image</a:t>
             </a:r>
           </a:p>
           <a:p>
             <a:pPr marL="0" indent="0">
               <a:buNone/>
             </a:pPr>
-            <a:r>
-              <a:rPr lang="en-US" dirty="0"/>
-              <a:t>The goal is to make the hidden information invisible to unauthorized users.</a:t>
-            </a:r>
+            <a:endParaRPr lang="en-US" sz="2000" dirty="0">
+              <a:latin typeface="Arial" panose="020B0604020202020204" pitchFamily="34" charset="0"/>
+              <a:cs typeface="Arial" panose="020B0604020202020204" pitchFamily="34" charset="0"/>
+            </a:endParaRPr>
           </a:p>
           <a:p>
             <a:pPr marL="0" indent="0">
               <a:buNone/>
             </a:pPr>
-            <a:endParaRPr lang="en-US" dirty="0"/>
+            <a:r>
+              <a:rPr lang="en-US" sz="2000" dirty="0">
+                <a:latin typeface="Arial" panose="020B0604020202020204" pitchFamily="34" charset="0"/>
+                <a:cs typeface="Arial" panose="020B0604020202020204" pitchFamily="34" charset="0"/>
+              </a:rPr>
+              <a:t>The goal is to make sure the hidden information remain invisible to unintended receivers.</a:t>
+            </a:r>
+          </a:p>
+          <a:p>
+            <a:pPr marL="0" indent="0">
+              <a:buNone/>
+            </a:pPr>
+            <a:endParaRPr lang="en-US" dirty="0">
+              <a:latin typeface="Abadi" panose="020F0502020204030204" pitchFamily="34" charset="0"/>
+            </a:endParaRPr>
           </a:p>
         </p:txBody>
       </p:sp>
@@ -3743,7 +3787,13 @@
   <p:cSld>
     <p:spTree>
       <p:nvGrpSpPr>
-        <p:cNvPr id="1" name=""/>
+        <p:cNvPr id="1" name="">
+          <a:extLst>
+            <a:ext uri="{FF2B5EF4-FFF2-40B4-BE49-F238E27FC236}">
+              <a16:creationId xmlns:a16="http://schemas.microsoft.com/office/drawing/2014/main" id="{EC25DBB3-AC3E-7DDB-EC32-6418288B0FD0}"/>
+            </a:ext>
+          </a:extLst>
+        </p:cNvPr>
         <p:cNvGrpSpPr/>
         <p:nvPr/>
       </p:nvGrpSpPr>
@@ -3760,7 +3810,7 @@
           <p:cNvPr id="2" name="Title 1">
             <a:extLst>
               <a:ext uri="{FF2B5EF4-FFF2-40B4-BE49-F238E27FC236}">
-                <a16:creationId xmlns:a16="http://schemas.microsoft.com/office/drawing/2014/main" id="{B7A13D02-356C-4FEE-8E98-2C6DC0FCB9BC}"/>
+                <a16:creationId xmlns:a16="http://schemas.microsoft.com/office/drawing/2014/main" id="{2DA03B79-6CEB-DD4C-9ADC-DA033E36D535}"/>
               </a:ext>
             </a:extLst>
           </p:cNvPr>
@@ -3773,8 +3823,8 @@
         </p:nvSpPr>
         <p:spPr>
           <a:xfrm>
-            <a:off x="1261872" y="365760"/>
-            <a:ext cx="9692640" cy="735252"/>
+            <a:off x="596326" y="324013"/>
+            <a:ext cx="9692640" cy="714718"/>
           </a:xfrm>
         </p:spPr>
         <p:txBody>
@@ -3782,8 +3832,11 @@
           <a:lstStyle/>
           <a:p>
             <a:r>
-              <a:rPr lang="en-US" dirty="0"/>
-              <a:t>Types of Steganography</a:t>
+              <a:rPr lang="en-US" dirty="0">
+                <a:latin typeface="Arial" panose="020B0604020202020204" pitchFamily="34" charset="0"/>
+                <a:cs typeface="Arial" panose="020B0604020202020204" pitchFamily="34" charset="0"/>
+              </a:rPr>
+              <a:t>Steganography Types</a:t>
             </a:r>
           </a:p>
         </p:txBody>
@@ -3793,7 +3846,7 @@
           <p:cNvPr id="3" name="Content Placeholder 2">
             <a:extLst>
               <a:ext uri="{FF2B5EF4-FFF2-40B4-BE49-F238E27FC236}">
-                <a16:creationId xmlns:a16="http://schemas.microsoft.com/office/drawing/2014/main" id="{018F7130-C8D1-434C-A4CC-404686E0E572}"/>
+                <a16:creationId xmlns:a16="http://schemas.microsoft.com/office/drawing/2014/main" id="{6C4BB023-1613-1176-E6E0-628664678955}"/>
               </a:ext>
             </a:extLst>
           </p:cNvPr>
@@ -3804,82 +3857,167 @@
             <p:ph idx="1"/>
           </p:nvPr>
         </p:nvSpPr>
-        <p:spPr/>
-        <p:txBody>
-          <a:bodyPr/>
-          <a:lstStyle/>
-          <a:p>
-            <a:r>
-              <a:rPr lang="en-US" b="1" dirty="0"/>
+        <p:spPr>
+          <a:xfrm>
+            <a:off x="596326" y="1574157"/>
+            <a:ext cx="10058169" cy="4351337"/>
+          </a:xfrm>
+        </p:spPr>
+        <p:txBody>
+          <a:bodyPr/>
+          <a:lstStyle/>
+          <a:p>
+            <a:pPr>
+              <a:buFont typeface="Wingdings" panose="05000000000000000000" pitchFamily="2" charset="2"/>
+              <a:buChar char="Ø"/>
+            </a:pPr>
+            <a:r>
+              <a:rPr lang="en-US" sz="2000" dirty="0">
+                <a:latin typeface="Arial" panose="020B0604020202020204" pitchFamily="34" charset="0"/>
+                <a:cs typeface="Arial" panose="020B0604020202020204" pitchFamily="34" charset="0"/>
+              </a:rPr>
+              <a:t> </a:t>
+            </a:r>
+            <a:r>
+              <a:rPr lang="en-US" sz="2000" b="1" dirty="0">
+                <a:latin typeface="Arial" panose="020B0604020202020204" pitchFamily="34" charset="0"/>
+                <a:cs typeface="Arial" panose="020B0604020202020204" pitchFamily="34" charset="0"/>
+              </a:rPr>
               <a:t>Text Steganography</a:t>
             </a:r>
+            <a:r>
+              <a:rPr lang="en-US" sz="2000" dirty="0">
+                <a:latin typeface="Arial" panose="020B0604020202020204" pitchFamily="34" charset="0"/>
+                <a:cs typeface="Arial" panose="020B0604020202020204" pitchFamily="34" charset="0"/>
+              </a:rPr>
+              <a:t>: hiding information inside text documents.</a:t>
+            </a:r>
+          </a:p>
+          <a:p>
+            <a:pPr>
+              <a:buFont typeface="Wingdings" panose="05000000000000000000" pitchFamily="2" charset="2"/>
+              <a:buChar char="Ø"/>
+            </a:pPr>
+            <a:endParaRPr lang="en-US" sz="2000" dirty="0">
+              <a:latin typeface="Arial" panose="020B0604020202020204" pitchFamily="34" charset="0"/>
+              <a:cs typeface="Arial" panose="020B0604020202020204" pitchFamily="34" charset="0"/>
+            </a:endParaRPr>
+          </a:p>
+          <a:p>
+            <a:pPr>
+              <a:buFont typeface="Wingdings" panose="05000000000000000000" pitchFamily="2" charset="2"/>
+              <a:buChar char="Ø"/>
+            </a:pPr>
+            <a:r>
+              <a:rPr lang="en-US" sz="2000" dirty="0">
+                <a:latin typeface="Arial" panose="020B0604020202020204" pitchFamily="34" charset="0"/>
+                <a:cs typeface="Arial" panose="020B0604020202020204" pitchFamily="34" charset="0"/>
+              </a:rPr>
+              <a:t> </a:t>
+            </a:r>
+            <a:r>
+              <a:rPr lang="en-US" sz="2000" b="1" dirty="0">
+                <a:latin typeface="Arial" panose="020B0604020202020204" pitchFamily="34" charset="0"/>
+                <a:cs typeface="Arial" panose="020B0604020202020204" pitchFamily="34" charset="0"/>
+              </a:rPr>
+              <a:t>Image Steganography</a:t>
+            </a:r>
+            <a:r>
+              <a:rPr lang="en-US" sz="2000" dirty="0">
+                <a:latin typeface="Arial" panose="020B0604020202020204" pitchFamily="34" charset="0"/>
+                <a:cs typeface="Arial" panose="020B0604020202020204" pitchFamily="34" charset="0"/>
+              </a:rPr>
+              <a:t>: hiding information inside digital images.</a:t>
+            </a:r>
+          </a:p>
+          <a:p>
+            <a:pPr>
+              <a:buFont typeface="Wingdings" panose="05000000000000000000" pitchFamily="2" charset="2"/>
+              <a:buChar char="Ø"/>
+            </a:pPr>
+            <a:endParaRPr lang="en-US" sz="2000" dirty="0">
+              <a:latin typeface="Arial" panose="020B0604020202020204" pitchFamily="34" charset="0"/>
+              <a:cs typeface="Arial" panose="020B0604020202020204" pitchFamily="34" charset="0"/>
+            </a:endParaRPr>
+          </a:p>
+          <a:p>
+            <a:pPr>
+              <a:buFont typeface="Wingdings" panose="05000000000000000000" pitchFamily="2" charset="2"/>
+              <a:buChar char="Ø"/>
+            </a:pPr>
+            <a:r>
+              <a:rPr lang="en-US" sz="2000" dirty="0">
+                <a:latin typeface="Arial" panose="020B0604020202020204" pitchFamily="34" charset="0"/>
+                <a:cs typeface="Arial" panose="020B0604020202020204" pitchFamily="34" charset="0"/>
+              </a:rPr>
+              <a:t> </a:t>
+            </a:r>
+            <a:r>
+              <a:rPr lang="en-US" sz="2000" b="1" dirty="0">
+                <a:latin typeface="Arial" panose="020B0604020202020204" pitchFamily="34" charset="0"/>
+                <a:cs typeface="Arial" panose="020B0604020202020204" pitchFamily="34" charset="0"/>
+              </a:rPr>
+              <a:t>Audio Steganography</a:t>
+            </a:r>
+            <a:r>
+              <a:rPr lang="en-US" sz="2000" dirty="0">
+                <a:latin typeface="Arial" panose="020B0604020202020204" pitchFamily="34" charset="0"/>
+                <a:cs typeface="Arial" panose="020B0604020202020204" pitchFamily="34" charset="0"/>
+              </a:rPr>
+              <a:t>: hiding information inside audio files.</a:t>
+            </a:r>
+          </a:p>
+          <a:p>
+            <a:pPr>
+              <a:buFont typeface="Wingdings" panose="05000000000000000000" pitchFamily="2" charset="2"/>
+              <a:buChar char="Ø"/>
+            </a:pPr>
+            <a:endParaRPr lang="en-US" sz="2000" dirty="0">
+              <a:latin typeface="Arial" panose="020B0604020202020204" pitchFamily="34" charset="0"/>
+              <a:cs typeface="Arial" panose="020B0604020202020204" pitchFamily="34" charset="0"/>
+            </a:endParaRPr>
+          </a:p>
+          <a:p>
+            <a:pPr>
+              <a:buFont typeface="Wingdings" panose="05000000000000000000" pitchFamily="2" charset="2"/>
+              <a:buChar char="Ø"/>
+            </a:pPr>
+            <a:r>
+              <a:rPr lang="en-US" sz="2000" dirty="0">
+                <a:latin typeface="Arial" panose="020B0604020202020204" pitchFamily="34" charset="0"/>
+                <a:cs typeface="Arial" panose="020B0604020202020204" pitchFamily="34" charset="0"/>
+              </a:rPr>
+              <a:t> </a:t>
+            </a:r>
+            <a:r>
+              <a:rPr lang="en-US" sz="2000" b="1" dirty="0">
+                <a:latin typeface="Arial" panose="020B0604020202020204" pitchFamily="34" charset="0"/>
+                <a:cs typeface="Arial" panose="020B0604020202020204" pitchFamily="34" charset="0"/>
+              </a:rPr>
+              <a:t>Video Steganography</a:t>
+            </a:r>
+            <a:r>
+              <a:rPr lang="en-US" sz="2000" dirty="0">
+                <a:latin typeface="Arial" panose="020B0604020202020204" pitchFamily="34" charset="0"/>
+                <a:cs typeface="Arial" panose="020B0604020202020204" pitchFamily="34" charset="0"/>
+              </a:rPr>
+              <a:t>: hiding information inside video files.</a:t>
+            </a:r>
           </a:p>
           <a:p>
             <a:pPr marL="0" indent="0">
               <a:buNone/>
             </a:pPr>
-            <a:r>
-              <a:rPr lang="en-US" dirty="0"/>
-              <a:t>Hiding information inside text documents.</a:t>
-            </a:r>
-          </a:p>
-          <a:p>
-            <a:r>
-              <a:rPr lang="en-US" b="1" dirty="0"/>
-              <a:t>Image Steganography</a:t>
-            </a:r>
-          </a:p>
-          <a:p>
-            <a:pPr marL="0" indent="0">
-              <a:buNone/>
-            </a:pPr>
-            <a:r>
-              <a:rPr lang="en-US" dirty="0"/>
-              <a:t>Hiding information inside digital images.</a:t>
-            </a:r>
-          </a:p>
-          <a:p>
-            <a:r>
-              <a:rPr lang="en-US" b="1" dirty="0"/>
-              <a:t>Audio Steganography</a:t>
-            </a:r>
-          </a:p>
-          <a:p>
-            <a:pPr marL="0" indent="0">
-              <a:buNone/>
-            </a:pPr>
-            <a:r>
-              <a:rPr lang="en-US" dirty="0"/>
-              <a:t>Hiding information inside audio files.</a:t>
-            </a:r>
-          </a:p>
-          <a:p>
-            <a:r>
-              <a:rPr lang="en-US" b="1" dirty="0"/>
-              <a:t>Video Steganography</a:t>
-            </a:r>
-          </a:p>
-          <a:p>
-            <a:pPr marL="0" indent="0">
-              <a:buNone/>
-            </a:pPr>
-            <a:r>
-              <a:rPr lang="en-US" dirty="0"/>
-              <a:t>Hiding information inside videos.</a:t>
-            </a:r>
-          </a:p>
-          <a:p>
-            <a:pPr marL="0" indent="0">
-              <a:buNone/>
-            </a:pPr>
-            <a:endParaRPr lang="en-US" dirty="0"/>
+            <a:endParaRPr lang="en-US" dirty="0">
+              <a:latin typeface="Abadi" panose="020F0502020204030204" pitchFamily="34" charset="0"/>
+            </a:endParaRPr>
           </a:p>
         </p:txBody>
       </p:sp>
     </p:spTree>
     <p:extLst>
       <p:ext uri="{BB962C8B-B14F-4D97-AF65-F5344CB8AC3E}">
-        <p14:creationId xmlns:p14="http://schemas.microsoft.com/office/powerpoint/2010/main" val="3060488503"/>
+        <p14:creationId xmlns:p14="http://schemas.microsoft.com/office/powerpoint/2010/main" val="3098776546"/>
       </p:ext>
     </p:extLst>
   </p:cSld>

</xml_diff>

<commit_message>
Add an image to the (What is Steganography) Slide
The edit is intended for clarification.
</commit_message>
<xml_diff>
--- a/steganographySlides.pptx
+++ b/steganographySlides.pptx
@@ -3661,7 +3661,7 @@
         <p:spPr>
           <a:xfrm>
             <a:off x="596326" y="1574157"/>
-            <a:ext cx="10058169" cy="4351337"/>
+            <a:ext cx="10278089" cy="4351337"/>
           </a:xfrm>
         </p:spPr>
         <p:txBody>
@@ -3683,59 +3683,7 @@
                 <a:latin typeface="Arial" panose="020B0604020202020204" pitchFamily="34" charset="0"/>
                 <a:cs typeface="Arial" panose="020B0604020202020204" pitchFamily="34" charset="0"/>
               </a:rPr>
-              <a:t> is the practice of hiding information inside another information object, such as:</a:t>
-            </a:r>
-          </a:p>
-          <a:p>
-            <a:pPr>
-              <a:buFont typeface="Arial" panose="020B0604020202020204" pitchFamily="34" charset="0"/>
-              <a:buChar char="•"/>
-            </a:pPr>
-            <a:r>
-              <a:rPr lang="en-US" sz="2000" dirty="0">
-                <a:latin typeface="Arial" panose="020B0604020202020204" pitchFamily="34" charset="0"/>
-                <a:cs typeface="Arial" panose="020B0604020202020204" pitchFamily="34" charset="0"/>
-              </a:rPr>
-              <a:t>Text inside an image</a:t>
-            </a:r>
-          </a:p>
-          <a:p>
-            <a:pPr>
-              <a:buFont typeface="Arial" panose="020B0604020202020204" pitchFamily="34" charset="0"/>
-              <a:buChar char="•"/>
-            </a:pPr>
-            <a:r>
-              <a:rPr lang="en-US" sz="2000" dirty="0">
-                <a:latin typeface="Arial" panose="020B0604020202020204" pitchFamily="34" charset="0"/>
-                <a:cs typeface="Arial" panose="020B0604020202020204" pitchFamily="34" charset="0"/>
-              </a:rPr>
-              <a:t>Text inside another text</a:t>
-            </a:r>
-          </a:p>
-          <a:p>
-            <a:pPr>
-              <a:buFont typeface="Arial" panose="020B0604020202020204" pitchFamily="34" charset="0"/>
-              <a:buChar char="•"/>
-            </a:pPr>
-            <a:r>
-              <a:rPr lang="en-US" sz="2000" dirty="0">
-                <a:latin typeface="Arial" panose="020B0604020202020204" pitchFamily="34" charset="0"/>
-                <a:cs typeface="Arial" panose="020B0604020202020204" pitchFamily="34" charset="0"/>
-              </a:rPr>
-              <a:t>Audio inside video</a:t>
-            </a:r>
-          </a:p>
-          <a:p>
-            <a:pPr>
-              <a:buFont typeface="Arial" panose="020B0604020202020204" pitchFamily="34" charset="0"/>
-              <a:buChar char="•"/>
-            </a:pPr>
-            <a:r>
-              <a:rPr lang="en-US" sz="2000" dirty="0">
-                <a:latin typeface="Arial" panose="020B0604020202020204" pitchFamily="34" charset="0"/>
-                <a:cs typeface="Arial" panose="020B0604020202020204" pitchFamily="34" charset="0"/>
-              </a:rPr>
-              <a:t>Image inside another image</a:t>
+              <a:t> is the practice of hiding information inside another information object, such as a text message that is hidden inside an image.</a:t>
             </a:r>
           </a:p>
           <a:p>
@@ -3765,6 +3713,184 @@
             </a:pPr>
             <a:endParaRPr lang="en-US" dirty="0">
               <a:latin typeface="Abadi" panose="020F0502020204030204" pitchFamily="34" charset="0"/>
+            </a:endParaRPr>
+          </a:p>
+        </p:txBody>
+      </p:sp>
+      <p:pic>
+        <p:nvPicPr>
+          <p:cNvPr id="7" name="Picture 6" descr="White circuit board pattern">
+            <a:extLst>
+              <a:ext uri="{FF2B5EF4-FFF2-40B4-BE49-F238E27FC236}">
+                <a16:creationId xmlns:a16="http://schemas.microsoft.com/office/drawing/2014/main" id="{CCD4C467-2D00-C73E-5CC9-78B638345A3A}"/>
+              </a:ext>
+            </a:extLst>
+          </p:cNvPr>
+          <p:cNvPicPr>
+            <a:picLocks noChangeAspect="1"/>
+          </p:cNvPicPr>
+          <p:nvPr/>
+        </p:nvPicPr>
+        <p:blipFill>
+          <a:blip r:embed="rId2">
+            <a:extLst>
+              <a:ext uri="{28A0092B-C50C-407E-A947-70E740481C1C}">
+                <a14:useLocalDpi xmlns:a14="http://schemas.microsoft.com/office/drawing/2010/main" val="0"/>
+              </a:ext>
+            </a:extLst>
+          </a:blip>
+          <a:stretch>
+            <a:fillRect/>
+          </a:stretch>
+        </p:blipFill>
+        <p:spPr>
+          <a:xfrm>
+            <a:off x="947225" y="3731788"/>
+            <a:ext cx="3638843" cy="2729132"/>
+          </a:xfrm>
+          <a:prstGeom prst="rect">
+            <a:avLst/>
+          </a:prstGeom>
+        </p:spPr>
+      </p:pic>
+      <p:cxnSp>
+        <p:nvCxnSpPr>
+          <p:cNvPr id="10" name="Straight Connector 9">
+            <a:extLst>
+              <a:ext uri="{FF2B5EF4-FFF2-40B4-BE49-F238E27FC236}">
+                <a16:creationId xmlns:a16="http://schemas.microsoft.com/office/drawing/2014/main" id="{1A58A826-0B35-DB1C-B818-24F54D1170AB}"/>
+              </a:ext>
+            </a:extLst>
+          </p:cNvPr>
+          <p:cNvCxnSpPr>
+            <a:cxnSpLocks/>
+            <a:stCxn id="8" idx="0"/>
+          </p:cNvCxnSpPr>
+          <p:nvPr/>
+        </p:nvCxnSpPr>
+        <p:spPr>
+          <a:xfrm flipH="1">
+            <a:off x="3044142" y="4329110"/>
+            <a:ext cx="3331060" cy="278924"/>
+          </a:xfrm>
+          <a:prstGeom prst="line">
+            <a:avLst/>
+          </a:prstGeom>
+          <a:ln w="38100"/>
+        </p:spPr>
+        <p:style>
+          <a:lnRef idx="1">
+            <a:schemeClr val="accent1"/>
+          </a:lnRef>
+          <a:fillRef idx="0">
+            <a:schemeClr val="accent1"/>
+          </a:fillRef>
+          <a:effectRef idx="0">
+            <a:schemeClr val="accent1"/>
+          </a:effectRef>
+          <a:fontRef idx="minor">
+            <a:schemeClr val="tx1"/>
+          </a:fontRef>
+        </p:style>
+      </p:cxnSp>
+      <p:cxnSp>
+        <p:nvCxnSpPr>
+          <p:cNvPr id="11" name="Straight Connector 10">
+            <a:extLst>
+              <a:ext uri="{FF2B5EF4-FFF2-40B4-BE49-F238E27FC236}">
+                <a16:creationId xmlns:a16="http://schemas.microsoft.com/office/drawing/2014/main" id="{2BE2FD45-ABCB-7B0B-C1C0-F2CC28548F84}"/>
+              </a:ext>
+            </a:extLst>
+          </p:cNvPr>
+          <p:cNvCxnSpPr>
+            <a:cxnSpLocks/>
+            <a:stCxn id="8" idx="4"/>
+          </p:cNvCxnSpPr>
+          <p:nvPr/>
+        </p:nvCxnSpPr>
+        <p:spPr>
+          <a:xfrm flipH="1" flipV="1">
+            <a:off x="2992056" y="4774557"/>
+            <a:ext cx="3383146" cy="1284078"/>
+          </a:xfrm>
+          <a:prstGeom prst="line">
+            <a:avLst/>
+          </a:prstGeom>
+          <a:ln w="38100"/>
+        </p:spPr>
+        <p:style>
+          <a:lnRef idx="1">
+            <a:schemeClr val="accent1"/>
+          </a:lnRef>
+          <a:fillRef idx="0">
+            <a:schemeClr val="accent1"/>
+          </a:fillRef>
+          <a:effectRef idx="0">
+            <a:schemeClr val="accent1"/>
+          </a:effectRef>
+          <a:fontRef idx="minor">
+            <a:schemeClr val="tx1"/>
+          </a:fontRef>
+        </p:style>
+      </p:cxnSp>
+      <p:sp>
+        <p:nvSpPr>
+          <p:cNvPr id="8" name="Oval 7">
+            <a:extLst>
+              <a:ext uri="{FF2B5EF4-FFF2-40B4-BE49-F238E27FC236}">
+                <a16:creationId xmlns:a16="http://schemas.microsoft.com/office/drawing/2014/main" id="{4819AF02-3A47-1205-7608-11BDE9866A6A}"/>
+              </a:ext>
+            </a:extLst>
+          </p:cNvPr>
+          <p:cNvSpPr/>
+          <p:nvPr/>
+        </p:nvSpPr>
+        <p:spPr>
+          <a:xfrm>
+            <a:off x="5510439" y="4329110"/>
+            <a:ext cx="1729525" cy="1729525"/>
+          </a:xfrm>
+          <a:prstGeom prst="ellipse">
+            <a:avLst/>
+          </a:prstGeom>
+          <a:solidFill>
+            <a:schemeClr val="bg1"/>
+          </a:solidFill>
+          <a:ln w="38100"/>
+        </p:spPr>
+        <p:style>
+          <a:lnRef idx="2">
+            <a:schemeClr val="accent1">
+              <a:shade val="15000"/>
+            </a:schemeClr>
+          </a:lnRef>
+          <a:fillRef idx="1">
+            <a:schemeClr val="accent1"/>
+          </a:fillRef>
+          <a:effectRef idx="0">
+            <a:schemeClr val="accent1"/>
+          </a:effectRef>
+          <a:fontRef idx="minor">
+            <a:schemeClr val="lt1"/>
+          </a:fontRef>
+        </p:style>
+        <p:txBody>
+          <a:bodyPr rtlCol="0" anchor="ctr"/>
+          <a:lstStyle/>
+          <a:p>
+            <a:pPr algn="ctr"/>
+            <a:r>
+              <a:rPr lang="en-US" sz="2000" dirty="0">
+                <a:solidFill>
+                  <a:srgbClr val="002060"/>
+                </a:solidFill>
+              </a:rPr>
+              <a:t>Hi, Seneca!</a:t>
+            </a:r>
+            <a:endParaRPr lang="en-CA" sz="2000" dirty="0">
+              <a:solidFill>
+                <a:srgbClr val="002060"/>
+              </a:solidFill>
             </a:endParaRPr>
           </a:p>
         </p:txBody>
@@ -3859,7 +3985,7 @@
         </p:nvSpPr>
         <p:spPr>
           <a:xfrm>
-            <a:off x="596326" y="1574157"/>
+            <a:off x="596326" y="1794076"/>
             <a:ext cx="10058169" cy="4351337"/>
           </a:xfrm>
         </p:spPr>

</xml_diff>

<commit_message>
Changing the slides color tone
</commit_message>
<xml_diff>
--- a/steganographySlides.pptx
+++ b/steganographySlides.pptx
@@ -3500,8 +3500,24 @@
           <a:lstStyle/>
           <a:p>
             <a:r>
-              <a:rPr lang="en-US" b="1" dirty="0"/>
-              <a:t>Steganography: Hiding Information in Digital Media</a:t>
+              <a:rPr lang="en-US" b="1" dirty="0">
+                <a:latin typeface="Arial" panose="020B0604020202020204" pitchFamily="34" charset="0"/>
+                <a:cs typeface="Arial" panose="020B0604020202020204" pitchFamily="34" charset="0"/>
+              </a:rPr>
+              <a:t>Steganography: </a:t>
+            </a:r>
+            <a:br>
+              <a:rPr lang="en-US" b="1" dirty="0">
+                <a:latin typeface="Arial" panose="020B0604020202020204" pitchFamily="34" charset="0"/>
+                <a:cs typeface="Arial" panose="020B0604020202020204" pitchFamily="34" charset="0"/>
+              </a:rPr>
+            </a:br>
+            <a:r>
+              <a:rPr lang="en-US" b="1" dirty="0">
+                <a:latin typeface="Arial" panose="020B0604020202020204" pitchFamily="34" charset="0"/>
+                <a:cs typeface="Arial" panose="020B0604020202020204" pitchFamily="34" charset="0"/>
+              </a:rPr>
+              <a:t>Hiding Information in Digital Media</a:t>
             </a:r>
           </a:p>
         </p:txBody>
@@ -3530,12 +3546,15 @@
         </p:spPr>
         <p:txBody>
           <a:bodyPr>
-            <a:normAutofit fontScale="70000" lnSpcReduction="20000"/>
+            <a:normAutofit fontScale="55000" lnSpcReduction="20000"/>
           </a:bodyPr>
           <a:lstStyle/>
           <a:p>
             <a:r>
-              <a:rPr lang="en-US" sz="3300" dirty="0"/>
+              <a:rPr lang="en-US" sz="3200" b="1" dirty="0">
+                <a:latin typeface="Arial" panose="020B0604020202020204" pitchFamily="34" charset="0"/>
+                <a:cs typeface="Arial" panose="020B0604020202020204" pitchFamily="34" charset="0"/>
+              </a:rPr>
               <a:t>Group Members:</a:t>
             </a:r>
           </a:p>
@@ -3546,24 +3565,42 @@
               </a:lnSpc>
             </a:pPr>
             <a:br>
-              <a:rPr lang="en-US" dirty="0"/>
+              <a:rPr lang="en-US" sz="3200" dirty="0">
+                <a:latin typeface="Arial" panose="020B0604020202020204" pitchFamily="34" charset="0"/>
+                <a:cs typeface="Arial" panose="020B0604020202020204" pitchFamily="34" charset="0"/>
+              </a:rPr>
             </a:br>
             <a:r>
-              <a:rPr lang="it-IT" sz="2600" dirty="0"/>
+              <a:rPr lang="it-IT" sz="3200" dirty="0">
+                <a:latin typeface="Arial" panose="020B0604020202020204" pitchFamily="34" charset="0"/>
+                <a:cs typeface="Arial" panose="020B0604020202020204" pitchFamily="34" charset="0"/>
+              </a:rPr>
               <a:t>Shima Vosoogh </a:t>
             </a:r>
             <a:br>
-              <a:rPr lang="it-IT" sz="2600" dirty="0"/>
+              <a:rPr lang="it-IT" sz="3200" dirty="0">
+                <a:latin typeface="Arial" panose="020B0604020202020204" pitchFamily="34" charset="0"/>
+                <a:cs typeface="Arial" panose="020B0604020202020204" pitchFamily="34" charset="0"/>
+              </a:rPr>
             </a:br>
             <a:r>
-              <a:rPr lang="it-IT" sz="2600" dirty="0"/>
+              <a:rPr lang="it-IT" sz="3200" dirty="0">
+                <a:latin typeface="Arial" panose="020B0604020202020204" pitchFamily="34" charset="0"/>
+                <a:cs typeface="Arial" panose="020B0604020202020204" pitchFamily="34" charset="0"/>
+              </a:rPr>
               <a:t>Rafia Riana</a:t>
             </a:r>
             <a:br>
-              <a:rPr lang="en-US" sz="2600" dirty="0"/>
+              <a:rPr lang="en-US" sz="3200" dirty="0">
+                <a:latin typeface="Arial" panose="020B0604020202020204" pitchFamily="34" charset="0"/>
+                <a:cs typeface="Arial" panose="020B0604020202020204" pitchFamily="34" charset="0"/>
+              </a:rPr>
             </a:br>
             <a:r>
-              <a:rPr lang="it-IT" sz="2600" dirty="0"/>
+              <a:rPr lang="it-IT" sz="3200" dirty="0">
+                <a:latin typeface="Arial" panose="020B0604020202020204" pitchFamily="34" charset="0"/>
+                <a:cs typeface="Arial" panose="020B0604020202020204" pitchFamily="34" charset="0"/>
+              </a:rPr>
               <a:t>Gulpari Alandarova</a:t>
             </a:r>
           </a:p>
@@ -4701,42 +4738,42 @@
 <file path=ppt/theme/theme1.xml><?xml version="1.0" encoding="utf-8"?>
 <a:theme xmlns:a="http://schemas.openxmlformats.org/drawingml/2006/main" name="View">
   <a:themeElements>
-    <a:clrScheme name="View">
+    <a:clrScheme name="Blue">
       <a:dk1>
-        <a:srgbClr val="000000"/>
+        <a:sysClr val="windowText" lastClr="000000"/>
       </a:dk1>
       <a:lt1>
-        <a:srgbClr val="FFFFFF"/>
+        <a:sysClr val="window" lastClr="FFFFFF"/>
       </a:lt1>
       <a:dk2>
-        <a:srgbClr val="46464A"/>
+        <a:srgbClr val="17406D"/>
       </a:dk2>
       <a:lt2>
-        <a:srgbClr val="D6D3CC"/>
+        <a:srgbClr val="DBEFF9"/>
       </a:lt2>
       <a:accent1>
-        <a:srgbClr val="6F6F74"/>
+        <a:srgbClr val="0F6FC6"/>
       </a:accent1>
       <a:accent2>
-        <a:srgbClr val="92A9B9"/>
+        <a:srgbClr val="009DD9"/>
       </a:accent2>
       <a:accent3>
-        <a:srgbClr val="A7B789"/>
+        <a:srgbClr val="0BD0D9"/>
       </a:accent3>
       <a:accent4>
-        <a:srgbClr val="B9A489"/>
+        <a:srgbClr val="10CF9B"/>
       </a:accent4>
       <a:accent5>
-        <a:srgbClr val="8D6374"/>
+        <a:srgbClr val="7CCA62"/>
       </a:accent5>
       <a:accent6>
-        <a:srgbClr val="9B7362"/>
+        <a:srgbClr val="A5C249"/>
       </a:accent6>
       <a:hlink>
-        <a:srgbClr val="67AABF"/>
+        <a:srgbClr val="F49100"/>
       </a:hlink>
       <a:folHlink>
-        <a:srgbClr val="ABAFA5"/>
+        <a:srgbClr val="85DFD0"/>
       </a:folHlink>
     </a:clrScheme>
     <a:fontScheme name="View">

</xml_diff>

<commit_message>
Adding my slides for text steganography
</commit_message>
<xml_diff>
--- a/steganographySlides.pptx
+++ b/steganographySlides.pptx
@@ -10,6 +10,10 @@
     <p:sldId id="263" r:id="rId4"/>
     <p:sldId id="261" r:id="rId5"/>
     <p:sldId id="262" r:id="rId6"/>
+    <p:sldId id="264" r:id="rId7"/>
+    <p:sldId id="265" r:id="rId8"/>
+    <p:sldId id="266" r:id="rId9"/>
+    <p:sldId id="267" r:id="rId10"/>
   </p:sldIdLst>
   <p:sldSz cx="12192000" cy="6858000"/>
   <p:notesSz cx="6858000" cy="9144000"/>
@@ -3720,7 +3724,7 @@
                 <a:latin typeface="Arial" panose="020B0604020202020204" pitchFamily="34" charset="0"/>
                 <a:cs typeface="Arial" panose="020B0604020202020204" pitchFamily="34" charset="0"/>
               </a:rPr>
-              <a:t> is the practice of hiding information inside another information object, such as a text message that is hidden inside an image.</a:t>
+              <a:t> is the practice of hiding information inside another information object (called carrier), such as a text message that is hidden inside an image.</a:t>
             </a:r>
           </a:p>
           <a:p>
@@ -4726,6 +4730,835 @@
     <p:extLst>
       <p:ext uri="{BB962C8B-B14F-4D97-AF65-F5344CB8AC3E}">
         <p14:creationId xmlns:p14="http://schemas.microsoft.com/office/powerpoint/2010/main" val="1480356791"/>
+      </p:ext>
+    </p:extLst>
+  </p:cSld>
+  <p:clrMapOvr>
+    <a:masterClrMapping/>
+  </p:clrMapOvr>
+</p:sld>
+</file>
+
+<file path=ppt/slides/slide6.xml><?xml version="1.0" encoding="utf-8"?>
+<p:sld xmlns:a="http://schemas.openxmlformats.org/drawingml/2006/main" xmlns:r="http://schemas.openxmlformats.org/officeDocument/2006/relationships" xmlns:p="http://schemas.openxmlformats.org/presentationml/2006/main">
+  <p:cSld>
+    <p:spTree>
+      <p:nvGrpSpPr>
+        <p:cNvPr id="1" name="">
+          <a:extLst>
+            <a:ext uri="{FF2B5EF4-FFF2-40B4-BE49-F238E27FC236}">
+              <a16:creationId xmlns:a16="http://schemas.microsoft.com/office/drawing/2014/main" id="{65740D3F-B3FA-8ED4-9B11-1D4E2D543E6B}"/>
+            </a:ext>
+          </a:extLst>
+        </p:cNvPr>
+        <p:cNvGrpSpPr/>
+        <p:nvPr/>
+      </p:nvGrpSpPr>
+      <p:grpSpPr>
+        <a:xfrm>
+          <a:off x="0" y="0"/>
+          <a:ext cx="0" cy="0"/>
+          <a:chOff x="0" y="0"/>
+          <a:chExt cx="0" cy="0"/>
+        </a:xfrm>
+      </p:grpSpPr>
+      <p:sp>
+        <p:nvSpPr>
+          <p:cNvPr id="2" name="Title 1">
+            <a:extLst>
+              <a:ext uri="{FF2B5EF4-FFF2-40B4-BE49-F238E27FC236}">
+                <a16:creationId xmlns:a16="http://schemas.microsoft.com/office/drawing/2014/main" id="{9F94ADBF-28D9-A846-9A19-BADC8161FA18}"/>
+              </a:ext>
+            </a:extLst>
+          </p:cNvPr>
+          <p:cNvSpPr>
+            <a:spLocks noGrp="1"/>
+          </p:cNvSpPr>
+          <p:nvPr>
+            <p:ph type="title"/>
+          </p:nvPr>
+        </p:nvSpPr>
+        <p:spPr>
+          <a:xfrm>
+            <a:off x="596326" y="324013"/>
+            <a:ext cx="9692640" cy="714718"/>
+          </a:xfrm>
+        </p:spPr>
+        <p:txBody>
+          <a:bodyPr/>
+          <a:lstStyle/>
+          <a:p>
+            <a:r>
+              <a:rPr lang="en-US" dirty="0">
+                <a:latin typeface="Arial" panose="020B0604020202020204" pitchFamily="34" charset="0"/>
+                <a:cs typeface="Arial" panose="020B0604020202020204" pitchFamily="34" charset="0"/>
+              </a:rPr>
+              <a:t>What is Text Steganography?</a:t>
+            </a:r>
+          </a:p>
+        </p:txBody>
+      </p:sp>
+      <p:sp>
+        <p:nvSpPr>
+          <p:cNvPr id="3" name="Content Placeholder 2">
+            <a:extLst>
+              <a:ext uri="{FF2B5EF4-FFF2-40B4-BE49-F238E27FC236}">
+                <a16:creationId xmlns:a16="http://schemas.microsoft.com/office/drawing/2014/main" id="{353F60A0-500B-2161-BB70-1F812E45F0AB}"/>
+              </a:ext>
+            </a:extLst>
+          </p:cNvPr>
+          <p:cNvSpPr>
+            <a:spLocks noGrp="1"/>
+          </p:cNvSpPr>
+          <p:nvPr>
+            <p:ph idx="1"/>
+          </p:nvPr>
+        </p:nvSpPr>
+        <p:spPr>
+          <a:xfrm>
+            <a:off x="596326" y="1574157"/>
+            <a:ext cx="10278089" cy="4351337"/>
+          </a:xfrm>
+        </p:spPr>
+        <p:txBody>
+          <a:bodyPr/>
+          <a:lstStyle/>
+          <a:p>
+            <a:pPr marL="0" indent="0">
+              <a:buNone/>
+            </a:pPr>
+            <a:endParaRPr lang="en-US" sz="2000" b="1" dirty="0">
+              <a:latin typeface="Arial" panose="020B0604020202020204" pitchFamily="34" charset="0"/>
+              <a:cs typeface="Arial" panose="020B0604020202020204" pitchFamily="34" charset="0"/>
+            </a:endParaRPr>
+          </a:p>
+          <a:p>
+            <a:pPr>
+              <a:buFont typeface="Wingdings" panose="05000000000000000000" pitchFamily="2" charset="2"/>
+              <a:buChar char="Ø"/>
+            </a:pPr>
+            <a:r>
+              <a:rPr lang="en-US" sz="2000" b="1" dirty="0">
+                <a:latin typeface="Arial" panose="020B0604020202020204" pitchFamily="34" charset="0"/>
+                <a:cs typeface="Arial" panose="020B0604020202020204" pitchFamily="34" charset="0"/>
+              </a:rPr>
+              <a:t> Text Steganography</a:t>
+            </a:r>
+            <a:r>
+              <a:rPr lang="en-US" sz="2000" dirty="0">
+                <a:latin typeface="Arial" panose="020B0604020202020204" pitchFamily="34" charset="0"/>
+                <a:cs typeface="Arial" panose="020B0604020202020204" pitchFamily="34" charset="0"/>
+              </a:rPr>
+              <a:t> is the practice of hiding text information inside another text object such as a digital book or a document.</a:t>
+            </a:r>
+          </a:p>
+          <a:p>
+            <a:pPr>
+              <a:buFont typeface="Wingdings" panose="05000000000000000000" pitchFamily="2" charset="2"/>
+              <a:buChar char="Ø"/>
+            </a:pPr>
+            <a:endParaRPr lang="en-US" sz="2000" dirty="0">
+              <a:latin typeface="Abadi" panose="020F0502020204030204" pitchFamily="34" charset="0"/>
+              <a:cs typeface="Arial" panose="020B0604020202020204" pitchFamily="34" charset="0"/>
+            </a:endParaRPr>
+          </a:p>
+          <a:p>
+            <a:pPr>
+              <a:buFont typeface="Wingdings" panose="05000000000000000000" pitchFamily="2" charset="2"/>
+              <a:buChar char="Ø"/>
+            </a:pPr>
+            <a:r>
+              <a:rPr lang="en-US" sz="2000" dirty="0">
+                <a:latin typeface="Abadi" panose="020F0502020204030204" pitchFamily="34" charset="0"/>
+                <a:cs typeface="Arial" panose="020B0604020202020204" pitchFamily="34" charset="0"/>
+              </a:rPr>
+              <a:t> Text steganography can be done by hiding non-text information inside text objects like audio in text. However, that first requires an audio to text conversion!</a:t>
+            </a:r>
+          </a:p>
+          <a:p>
+            <a:pPr>
+              <a:buFont typeface="Wingdings" panose="05000000000000000000" pitchFamily="2" charset="2"/>
+              <a:buChar char="Ø"/>
+            </a:pPr>
+            <a:endParaRPr lang="en-US" sz="2000" dirty="0">
+              <a:latin typeface="Abadi" panose="020F0502020204030204" pitchFamily="34" charset="0"/>
+              <a:cs typeface="Arial" panose="020B0604020202020204" pitchFamily="34" charset="0"/>
+            </a:endParaRPr>
+          </a:p>
+          <a:p>
+            <a:pPr>
+              <a:buFont typeface="Wingdings" panose="05000000000000000000" pitchFamily="2" charset="2"/>
+              <a:buChar char="Ø"/>
+            </a:pPr>
+            <a:r>
+              <a:rPr lang="en-US" sz="2000" dirty="0">
+                <a:latin typeface="Abadi" panose="020F0502020204030204" pitchFamily="34" charset="0"/>
+                <a:cs typeface="Arial" panose="020B0604020202020204" pitchFamily="34" charset="0"/>
+              </a:rPr>
+              <a:t> Text steganography is also one of the ancient forms of hiding information.</a:t>
+            </a:r>
+            <a:endParaRPr lang="en-US" sz="2000" dirty="0">
+              <a:latin typeface="Arial" panose="020B0604020202020204" pitchFamily="34" charset="0"/>
+              <a:cs typeface="Arial" panose="020B0604020202020204" pitchFamily="34" charset="0"/>
+            </a:endParaRPr>
+          </a:p>
+        </p:txBody>
+      </p:sp>
+    </p:spTree>
+    <p:extLst>
+      <p:ext uri="{BB962C8B-B14F-4D97-AF65-F5344CB8AC3E}">
+        <p14:creationId xmlns:p14="http://schemas.microsoft.com/office/powerpoint/2010/main" val="1390169804"/>
+      </p:ext>
+    </p:extLst>
+  </p:cSld>
+  <p:clrMapOvr>
+    <a:masterClrMapping/>
+  </p:clrMapOvr>
+</p:sld>
+</file>
+
+<file path=ppt/slides/slide7.xml><?xml version="1.0" encoding="utf-8"?>
+<p:sld xmlns:a="http://schemas.openxmlformats.org/drawingml/2006/main" xmlns:r="http://schemas.openxmlformats.org/officeDocument/2006/relationships" xmlns:p="http://schemas.openxmlformats.org/presentationml/2006/main">
+  <p:cSld>
+    <p:spTree>
+      <p:nvGrpSpPr>
+        <p:cNvPr id="1" name="">
+          <a:extLst>
+            <a:ext uri="{FF2B5EF4-FFF2-40B4-BE49-F238E27FC236}">
+              <a16:creationId xmlns:a16="http://schemas.microsoft.com/office/drawing/2014/main" id="{D68AF753-8CFF-202B-19CB-152C4EAA5386}"/>
+            </a:ext>
+          </a:extLst>
+        </p:cNvPr>
+        <p:cNvGrpSpPr/>
+        <p:nvPr/>
+      </p:nvGrpSpPr>
+      <p:grpSpPr>
+        <a:xfrm>
+          <a:off x="0" y="0"/>
+          <a:ext cx="0" cy="0"/>
+          <a:chOff x="0" y="0"/>
+          <a:chExt cx="0" cy="0"/>
+        </a:xfrm>
+      </p:grpSpPr>
+      <p:sp>
+        <p:nvSpPr>
+          <p:cNvPr id="2" name="Title 1">
+            <a:extLst>
+              <a:ext uri="{FF2B5EF4-FFF2-40B4-BE49-F238E27FC236}">
+                <a16:creationId xmlns:a16="http://schemas.microsoft.com/office/drawing/2014/main" id="{51208D7B-869F-CAE0-A544-696336D5FB07}"/>
+              </a:ext>
+            </a:extLst>
+          </p:cNvPr>
+          <p:cNvSpPr>
+            <a:spLocks noGrp="1"/>
+          </p:cNvSpPr>
+          <p:nvPr>
+            <p:ph type="title"/>
+          </p:nvPr>
+        </p:nvSpPr>
+        <p:spPr>
+          <a:xfrm>
+            <a:off x="422706" y="341378"/>
+            <a:ext cx="10625330" cy="717709"/>
+          </a:xfrm>
+        </p:spPr>
+        <p:txBody>
+          <a:bodyPr>
+            <a:normAutofit/>
+          </a:bodyPr>
+          <a:lstStyle/>
+          <a:p>
+            <a:r>
+              <a:rPr lang="en-US" dirty="0">
+                <a:latin typeface="Arial" panose="020B0604020202020204" pitchFamily="34" charset="0"/>
+                <a:cs typeface="Arial" panose="020B0604020202020204" pitchFamily="34" charset="0"/>
+              </a:rPr>
+              <a:t>Common Text Steganography Methods?</a:t>
+            </a:r>
+          </a:p>
+        </p:txBody>
+      </p:sp>
+      <p:sp>
+        <p:nvSpPr>
+          <p:cNvPr id="3" name="Content Placeholder 2">
+            <a:extLst>
+              <a:ext uri="{FF2B5EF4-FFF2-40B4-BE49-F238E27FC236}">
+                <a16:creationId xmlns:a16="http://schemas.microsoft.com/office/drawing/2014/main" id="{926B1959-7608-05BA-E7A3-FB8B9C323A5E}"/>
+              </a:ext>
+            </a:extLst>
+          </p:cNvPr>
+          <p:cNvSpPr>
+            <a:spLocks noGrp="1"/>
+          </p:cNvSpPr>
+          <p:nvPr>
+            <p:ph idx="1"/>
+          </p:nvPr>
+        </p:nvSpPr>
+        <p:spPr>
+          <a:xfrm>
+            <a:off x="596326" y="1574157"/>
+            <a:ext cx="10278089" cy="4351337"/>
+          </a:xfrm>
+        </p:spPr>
+        <p:txBody>
+          <a:bodyPr/>
+          <a:lstStyle/>
+          <a:p>
+            <a:pPr marL="0" indent="0">
+              <a:buNone/>
+            </a:pPr>
+            <a:endParaRPr lang="en-US" sz="2000" b="1" dirty="0">
+              <a:latin typeface="Arial" panose="020B0604020202020204" pitchFamily="34" charset="0"/>
+              <a:cs typeface="Arial" panose="020B0604020202020204" pitchFamily="34" charset="0"/>
+            </a:endParaRPr>
+          </a:p>
+          <a:p>
+            <a:pPr>
+              <a:lnSpc>
+                <a:spcPts val="2700"/>
+              </a:lnSpc>
+              <a:buFont typeface="Wingdings" panose="05000000000000000000" pitchFamily="2" charset="2"/>
+              <a:buChar char="Ø"/>
+            </a:pPr>
+            <a:r>
+              <a:rPr lang="en-US" sz="2000" b="1" dirty="0">
+                <a:latin typeface="Arial" panose="020B0604020202020204" pitchFamily="34" charset="0"/>
+                <a:cs typeface="Arial" panose="020B0604020202020204" pitchFamily="34" charset="0"/>
+              </a:rPr>
+              <a:t> Using sentence features</a:t>
+            </a:r>
+          </a:p>
+          <a:p>
+            <a:pPr lvl="1">
+              <a:lnSpc>
+                <a:spcPts val="2700"/>
+              </a:lnSpc>
+              <a:buFont typeface="Arial" panose="020B0604020202020204" pitchFamily="34" charset="0"/>
+              <a:buChar char="•"/>
+            </a:pPr>
+            <a:r>
+              <a:rPr lang="en-US" sz="1800" dirty="0">
+                <a:latin typeface="Arial" panose="020B0604020202020204" pitchFamily="34" charset="0"/>
+                <a:cs typeface="Arial" panose="020B0604020202020204" pitchFamily="34" charset="0"/>
+              </a:rPr>
+              <a:t>Taking advantage of punctuative letters like “,” and “.” to represent 0 and 1 of the ASCII codes for the hidden text letter.</a:t>
+            </a:r>
+          </a:p>
+          <a:p>
+            <a:pPr marL="274320" lvl="1" indent="0">
+              <a:lnSpc>
+                <a:spcPct val="100000"/>
+              </a:lnSpc>
+              <a:buNone/>
+            </a:pPr>
+            <a:endParaRPr lang="en-US" sz="1800" dirty="0">
+              <a:latin typeface="Arial" panose="020B0604020202020204" pitchFamily="34" charset="0"/>
+              <a:cs typeface="Arial" panose="020B0604020202020204" pitchFamily="34" charset="0"/>
+            </a:endParaRPr>
+          </a:p>
+          <a:p>
+            <a:pPr>
+              <a:lnSpc>
+                <a:spcPts val="2700"/>
+              </a:lnSpc>
+              <a:buFont typeface="Wingdings" panose="05000000000000000000" pitchFamily="2" charset="2"/>
+              <a:buChar char="Ø"/>
+            </a:pPr>
+            <a:r>
+              <a:rPr lang="en-US" sz="2000" b="1" dirty="0">
+                <a:latin typeface="Arial" panose="020B0604020202020204" pitchFamily="34" charset="0"/>
+                <a:cs typeface="Arial" panose="020B0604020202020204" pitchFamily="34" charset="0"/>
+              </a:rPr>
+              <a:t> Using the structure of the carrier object</a:t>
+            </a:r>
+          </a:p>
+          <a:p>
+            <a:pPr lvl="1">
+              <a:lnSpc>
+                <a:spcPts val="2700"/>
+              </a:lnSpc>
+              <a:buFont typeface="Arial" panose="020B0604020202020204" pitchFamily="34" charset="0"/>
+              <a:buChar char="•"/>
+            </a:pPr>
+            <a:r>
+              <a:rPr lang="en-US" sz="1800" dirty="0">
+                <a:latin typeface="Arial" panose="020B0604020202020204" pitchFamily="34" charset="0"/>
+                <a:cs typeface="Arial" panose="020B0604020202020204" pitchFamily="34" charset="0"/>
+              </a:rPr>
+              <a:t>Taking advantage of the tabs and spacing to represent the bits of the ASCII codes for the letters of the hidden text.</a:t>
+            </a:r>
+          </a:p>
+          <a:p>
+            <a:pPr marL="274320" lvl="1" indent="0">
+              <a:lnSpc>
+                <a:spcPct val="100000"/>
+              </a:lnSpc>
+              <a:buNone/>
+            </a:pPr>
+            <a:endParaRPr lang="en-US" sz="1800" dirty="0">
+              <a:latin typeface="Arial" panose="020B0604020202020204" pitchFamily="34" charset="0"/>
+              <a:cs typeface="Arial" panose="020B0604020202020204" pitchFamily="34" charset="0"/>
+            </a:endParaRPr>
+          </a:p>
+        </p:txBody>
+      </p:sp>
+    </p:spTree>
+    <p:extLst>
+      <p:ext uri="{BB962C8B-B14F-4D97-AF65-F5344CB8AC3E}">
+        <p14:creationId xmlns:p14="http://schemas.microsoft.com/office/powerpoint/2010/main" val="4036111973"/>
+      </p:ext>
+    </p:extLst>
+  </p:cSld>
+  <p:clrMapOvr>
+    <a:masterClrMapping/>
+  </p:clrMapOvr>
+</p:sld>
+</file>
+
+<file path=ppt/slides/slide8.xml><?xml version="1.0" encoding="utf-8"?>
+<p:sld xmlns:a="http://schemas.openxmlformats.org/drawingml/2006/main" xmlns:r="http://schemas.openxmlformats.org/officeDocument/2006/relationships" xmlns:p="http://schemas.openxmlformats.org/presentationml/2006/main">
+  <p:cSld>
+    <p:spTree>
+      <p:nvGrpSpPr>
+        <p:cNvPr id="1" name="">
+          <a:extLst>
+            <a:ext uri="{FF2B5EF4-FFF2-40B4-BE49-F238E27FC236}">
+              <a16:creationId xmlns:a16="http://schemas.microsoft.com/office/drawing/2014/main" id="{7A90092C-4552-A610-B91D-A4F37EB0BE01}"/>
+            </a:ext>
+          </a:extLst>
+        </p:cNvPr>
+        <p:cNvGrpSpPr/>
+        <p:nvPr/>
+      </p:nvGrpSpPr>
+      <p:grpSpPr>
+        <a:xfrm>
+          <a:off x="0" y="0"/>
+          <a:ext cx="0" cy="0"/>
+          <a:chOff x="0" y="0"/>
+          <a:chExt cx="0" cy="0"/>
+        </a:xfrm>
+      </p:grpSpPr>
+      <p:sp>
+        <p:nvSpPr>
+          <p:cNvPr id="2" name="Title 1">
+            <a:extLst>
+              <a:ext uri="{FF2B5EF4-FFF2-40B4-BE49-F238E27FC236}">
+                <a16:creationId xmlns:a16="http://schemas.microsoft.com/office/drawing/2014/main" id="{0914E720-B4D0-8DB6-202A-78F4FC30064E}"/>
+              </a:ext>
+            </a:extLst>
+          </p:cNvPr>
+          <p:cNvSpPr>
+            <a:spLocks noGrp="1"/>
+          </p:cNvSpPr>
+          <p:nvPr>
+            <p:ph type="title"/>
+          </p:nvPr>
+        </p:nvSpPr>
+        <p:spPr>
+          <a:xfrm>
+            <a:off x="422706" y="341378"/>
+            <a:ext cx="10625330" cy="717709"/>
+          </a:xfrm>
+        </p:spPr>
+        <p:txBody>
+          <a:bodyPr>
+            <a:normAutofit/>
+          </a:bodyPr>
+          <a:lstStyle/>
+          <a:p>
+            <a:r>
+              <a:rPr lang="en-US" dirty="0">
+                <a:latin typeface="Arial" panose="020B0604020202020204" pitchFamily="34" charset="0"/>
+                <a:cs typeface="Arial" panose="020B0604020202020204" pitchFamily="34" charset="0"/>
+              </a:rPr>
+              <a:t>Common Text Steganography Methods?</a:t>
+            </a:r>
+          </a:p>
+        </p:txBody>
+      </p:sp>
+      <p:sp>
+        <p:nvSpPr>
+          <p:cNvPr id="3" name="Content Placeholder 2">
+            <a:extLst>
+              <a:ext uri="{FF2B5EF4-FFF2-40B4-BE49-F238E27FC236}">
+                <a16:creationId xmlns:a16="http://schemas.microsoft.com/office/drawing/2014/main" id="{043AAD8C-CE48-E9B1-B973-049226043E90}"/>
+              </a:ext>
+            </a:extLst>
+          </p:cNvPr>
+          <p:cNvSpPr>
+            <a:spLocks noGrp="1"/>
+          </p:cNvSpPr>
+          <p:nvPr>
+            <p:ph idx="1"/>
+          </p:nvPr>
+        </p:nvSpPr>
+        <p:spPr>
+          <a:xfrm>
+            <a:off x="596327" y="1313725"/>
+            <a:ext cx="10063958" cy="4762983"/>
+          </a:xfrm>
+        </p:spPr>
+        <p:txBody>
+          <a:bodyPr>
+            <a:normAutofit fontScale="70000" lnSpcReduction="20000"/>
+          </a:bodyPr>
+          <a:lstStyle/>
+          <a:p>
+            <a:pPr marL="0" indent="0">
+              <a:buNone/>
+            </a:pPr>
+            <a:endParaRPr lang="en-US" sz="4500" b="1" dirty="0">
+              <a:latin typeface="Arial" panose="020B0604020202020204" pitchFamily="34" charset="0"/>
+              <a:cs typeface="Arial" panose="020B0604020202020204" pitchFamily="34" charset="0"/>
+            </a:endParaRPr>
+          </a:p>
+          <a:p>
+            <a:pPr>
+              <a:lnSpc>
+                <a:spcPts val="2700"/>
+              </a:lnSpc>
+              <a:buFont typeface="Wingdings" panose="05000000000000000000" pitchFamily="2" charset="2"/>
+              <a:buChar char="Ø"/>
+            </a:pPr>
+            <a:r>
+              <a:rPr lang="en-US" sz="2900" b="1" dirty="0">
+                <a:latin typeface="Arial" panose="020B0604020202020204" pitchFamily="34" charset="0"/>
+                <a:cs typeface="Arial" panose="020B0604020202020204" pitchFamily="34" charset="0"/>
+              </a:rPr>
+              <a:t> Using semantic modifications</a:t>
+            </a:r>
+          </a:p>
+          <a:p>
+            <a:pPr lvl="1">
+              <a:lnSpc>
+                <a:spcPts val="2700"/>
+              </a:lnSpc>
+              <a:buFont typeface="Arial" panose="020B0604020202020204" pitchFamily="34" charset="0"/>
+              <a:buChar char="•"/>
+            </a:pPr>
+            <a:r>
+              <a:rPr lang="en-US" sz="2900" dirty="0">
+                <a:latin typeface="Arial" panose="020B0604020202020204" pitchFamily="34" charset="0"/>
+                <a:cs typeface="Arial" panose="020B0604020202020204" pitchFamily="34" charset="0"/>
+              </a:rPr>
+              <a:t>Replacing highly frequent words in the carrier with their synonyms that contain letter of the hidden text.</a:t>
+            </a:r>
+          </a:p>
+          <a:p>
+            <a:pPr>
+              <a:lnSpc>
+                <a:spcPts val="2700"/>
+              </a:lnSpc>
+              <a:buFont typeface="Wingdings" panose="05000000000000000000" pitchFamily="2" charset="2"/>
+              <a:buChar char="Ø"/>
+            </a:pPr>
+            <a:r>
+              <a:rPr lang="en-US" sz="2900" b="1" dirty="0">
+                <a:latin typeface="Arial" panose="020B0604020202020204" pitchFamily="34" charset="0"/>
+                <a:cs typeface="Arial" panose="020B0604020202020204" pitchFamily="34" charset="0"/>
+              </a:rPr>
+              <a:t> Using file formats</a:t>
+            </a:r>
+          </a:p>
+          <a:p>
+            <a:pPr lvl="1">
+              <a:lnSpc>
+                <a:spcPts val="2700"/>
+              </a:lnSpc>
+              <a:buFont typeface="Arial" panose="020B0604020202020204" pitchFamily="34" charset="0"/>
+              <a:buChar char="•"/>
+            </a:pPr>
+            <a:r>
+              <a:rPr lang="en-US" sz="2900" dirty="0">
+                <a:latin typeface="Arial" panose="020B0604020202020204" pitchFamily="34" charset="0"/>
+                <a:cs typeface="Arial" panose="020B0604020202020204" pitchFamily="34" charset="0"/>
+              </a:rPr>
+              <a:t>Taking advantage of programming source code files to include hidden texts where applicable such as case-sensitive statements and variable names.</a:t>
+            </a:r>
+          </a:p>
+          <a:p>
+            <a:pPr>
+              <a:lnSpc>
+                <a:spcPts val="2700"/>
+              </a:lnSpc>
+              <a:buFont typeface="Wingdings" panose="05000000000000000000" pitchFamily="2" charset="2"/>
+              <a:buChar char="Ø"/>
+            </a:pPr>
+            <a:r>
+              <a:rPr lang="en-US" sz="2900" b="1" dirty="0">
+                <a:latin typeface="Arial" panose="020B0604020202020204" pitchFamily="34" charset="0"/>
+                <a:cs typeface="Arial" panose="020B0604020202020204" pitchFamily="34" charset="0"/>
+              </a:rPr>
+              <a:t> New: Generative AI</a:t>
+            </a:r>
+          </a:p>
+          <a:p>
+            <a:pPr lvl="1">
+              <a:lnSpc>
+                <a:spcPts val="2700"/>
+              </a:lnSpc>
+              <a:buFont typeface="Arial" panose="020B0604020202020204" pitchFamily="34" charset="0"/>
+              <a:buChar char="•"/>
+            </a:pPr>
+            <a:r>
+              <a:rPr lang="en-US" sz="2900" dirty="0">
+                <a:latin typeface="Arial" panose="020B0604020202020204" pitchFamily="34" charset="0"/>
+                <a:cs typeface="Arial" panose="020B0604020202020204" pitchFamily="34" charset="0"/>
+              </a:rPr>
+              <a:t>Taking advantage of generative AI capabilities to hide messages. Generative AI can produce invisible patterns and combine various methods like semantic and sentence features to hide the message.</a:t>
+            </a:r>
+          </a:p>
+          <a:p>
+            <a:pPr lvl="1">
+              <a:lnSpc>
+                <a:spcPts val="2700"/>
+              </a:lnSpc>
+              <a:buFont typeface="Arial" panose="020B0604020202020204" pitchFamily="34" charset="0"/>
+              <a:buChar char="•"/>
+            </a:pPr>
+            <a:endParaRPr lang="en-US" sz="1800" dirty="0">
+              <a:latin typeface="Arial" panose="020B0604020202020204" pitchFamily="34" charset="0"/>
+              <a:cs typeface="Arial" panose="020B0604020202020204" pitchFamily="34" charset="0"/>
+            </a:endParaRPr>
+          </a:p>
+          <a:p>
+            <a:pPr marL="274320" lvl="1" indent="0">
+              <a:lnSpc>
+                <a:spcPct val="100000"/>
+              </a:lnSpc>
+              <a:buNone/>
+            </a:pPr>
+            <a:endParaRPr lang="en-US" sz="1800" dirty="0">
+              <a:latin typeface="Arial" panose="020B0604020202020204" pitchFamily="34" charset="0"/>
+              <a:cs typeface="Arial" panose="020B0604020202020204" pitchFamily="34" charset="0"/>
+            </a:endParaRPr>
+          </a:p>
+        </p:txBody>
+      </p:sp>
+    </p:spTree>
+    <p:extLst>
+      <p:ext uri="{BB962C8B-B14F-4D97-AF65-F5344CB8AC3E}">
+        <p14:creationId xmlns:p14="http://schemas.microsoft.com/office/powerpoint/2010/main" val="809939034"/>
+      </p:ext>
+    </p:extLst>
+  </p:cSld>
+  <p:clrMapOvr>
+    <a:masterClrMapping/>
+  </p:clrMapOvr>
+</p:sld>
+</file>
+
+<file path=ppt/slides/slide9.xml><?xml version="1.0" encoding="utf-8"?>
+<p:sld xmlns:a="http://schemas.openxmlformats.org/drawingml/2006/main" xmlns:r="http://schemas.openxmlformats.org/officeDocument/2006/relationships" xmlns:p="http://schemas.openxmlformats.org/presentationml/2006/main">
+  <p:cSld>
+    <p:spTree>
+      <p:nvGrpSpPr>
+        <p:cNvPr id="1" name="">
+          <a:extLst>
+            <a:ext uri="{FF2B5EF4-FFF2-40B4-BE49-F238E27FC236}">
+              <a16:creationId xmlns:a16="http://schemas.microsoft.com/office/drawing/2014/main" id="{6955C251-3750-7D17-2890-A901AE194F53}"/>
+            </a:ext>
+          </a:extLst>
+        </p:cNvPr>
+        <p:cNvGrpSpPr/>
+        <p:nvPr/>
+      </p:nvGrpSpPr>
+      <p:grpSpPr>
+        <a:xfrm>
+          <a:off x="0" y="0"/>
+          <a:ext cx="0" cy="0"/>
+          <a:chOff x="0" y="0"/>
+          <a:chExt cx="0" cy="0"/>
+        </a:xfrm>
+      </p:grpSpPr>
+      <p:sp>
+        <p:nvSpPr>
+          <p:cNvPr id="2" name="Title 1">
+            <a:extLst>
+              <a:ext uri="{FF2B5EF4-FFF2-40B4-BE49-F238E27FC236}">
+                <a16:creationId xmlns:a16="http://schemas.microsoft.com/office/drawing/2014/main" id="{13C71C33-C97C-DA17-2E59-FCF359626C0E}"/>
+              </a:ext>
+            </a:extLst>
+          </p:cNvPr>
+          <p:cNvSpPr>
+            <a:spLocks noGrp="1"/>
+          </p:cNvSpPr>
+          <p:nvPr>
+            <p:ph type="title"/>
+          </p:nvPr>
+        </p:nvSpPr>
+        <p:spPr>
+          <a:xfrm>
+            <a:off x="422706" y="341378"/>
+            <a:ext cx="10625330" cy="717709"/>
+          </a:xfrm>
+        </p:spPr>
+        <p:txBody>
+          <a:bodyPr>
+            <a:normAutofit/>
+          </a:bodyPr>
+          <a:lstStyle/>
+          <a:p>
+            <a:r>
+              <a:rPr lang="en-US" dirty="0">
+                <a:latin typeface="Arial" panose="020B0604020202020204" pitchFamily="34" charset="0"/>
+                <a:cs typeface="Arial" panose="020B0604020202020204" pitchFamily="34" charset="0"/>
+              </a:rPr>
+              <a:t>Text Steganography Benefits</a:t>
+            </a:r>
+          </a:p>
+        </p:txBody>
+      </p:sp>
+      <p:sp>
+        <p:nvSpPr>
+          <p:cNvPr id="6" name="Content Placeholder 2">
+            <a:extLst>
+              <a:ext uri="{FF2B5EF4-FFF2-40B4-BE49-F238E27FC236}">
+                <a16:creationId xmlns:a16="http://schemas.microsoft.com/office/drawing/2014/main" id="{25562F33-0501-37A5-9098-86A5D7B4307E}"/>
+              </a:ext>
+            </a:extLst>
+          </p:cNvPr>
+          <p:cNvSpPr>
+            <a:spLocks noGrp="1"/>
+          </p:cNvSpPr>
+          <p:nvPr>
+            <p:ph idx="1"/>
+          </p:nvPr>
+        </p:nvSpPr>
+        <p:spPr>
+          <a:xfrm>
+            <a:off x="596326" y="1574157"/>
+            <a:ext cx="10006083" cy="4351337"/>
+          </a:xfrm>
+        </p:spPr>
+        <p:txBody>
+          <a:bodyPr>
+            <a:normAutofit/>
+          </a:bodyPr>
+          <a:lstStyle/>
+          <a:p>
+            <a:pPr marL="0" indent="0">
+              <a:buNone/>
+            </a:pPr>
+            <a:endParaRPr lang="en-US" sz="2000" b="1" dirty="0">
+              <a:latin typeface="Arial" panose="020B0604020202020204" pitchFamily="34" charset="0"/>
+              <a:cs typeface="Arial" panose="020B0604020202020204" pitchFamily="34" charset="0"/>
+            </a:endParaRPr>
+          </a:p>
+          <a:p>
+            <a:pPr marL="0" indent="0">
+              <a:lnSpc>
+                <a:spcPts val="2800"/>
+              </a:lnSpc>
+              <a:buNone/>
+            </a:pPr>
+            <a:r>
+              <a:rPr lang="en-US" sz="2000" dirty="0">
+                <a:latin typeface="Arial" panose="020B0604020202020204" pitchFamily="34" charset="0"/>
+                <a:cs typeface="Arial" panose="020B0604020202020204" pitchFamily="34" charset="0"/>
+              </a:rPr>
+              <a:t>Unlike text cryptography which makes information non-understandable, steganography hides information from an ordinary eye. </a:t>
+            </a:r>
+          </a:p>
+          <a:p>
+            <a:pPr marL="0" indent="0">
+              <a:lnSpc>
+                <a:spcPts val="2800"/>
+              </a:lnSpc>
+              <a:buNone/>
+            </a:pPr>
+            <a:r>
+              <a:rPr lang="en-US" sz="2000" dirty="0">
+                <a:latin typeface="Arial" panose="020B0604020202020204" pitchFamily="34" charset="0"/>
+                <a:cs typeface="Arial" panose="020B0604020202020204" pitchFamily="34" charset="0"/>
+              </a:rPr>
+              <a:t>Therefore, text steganography can be used to:</a:t>
+            </a:r>
+          </a:p>
+          <a:p>
+            <a:pPr marL="0" indent="0">
+              <a:lnSpc>
+                <a:spcPts val="500"/>
+              </a:lnSpc>
+              <a:buNone/>
+            </a:pPr>
+            <a:endParaRPr lang="en-US" sz="2000" dirty="0">
+              <a:latin typeface="Arial" panose="020B0604020202020204" pitchFamily="34" charset="0"/>
+              <a:cs typeface="Arial" panose="020B0604020202020204" pitchFamily="34" charset="0"/>
+            </a:endParaRPr>
+          </a:p>
+          <a:p>
+            <a:pPr>
+              <a:buFont typeface="Wingdings" panose="05000000000000000000" pitchFamily="2" charset="2"/>
+              <a:buChar char="Ø"/>
+            </a:pPr>
+            <a:r>
+              <a:rPr lang="en-US" sz="2000" dirty="0">
+                <a:latin typeface="Abadi" panose="020F0502020204030204" pitchFamily="34" charset="0"/>
+                <a:cs typeface="Arial" panose="020B0604020202020204" pitchFamily="34" charset="0"/>
+              </a:rPr>
+              <a:t> Hide the existence of a message</a:t>
+            </a:r>
+          </a:p>
+          <a:p>
+            <a:pPr>
+              <a:buFont typeface="Wingdings" panose="05000000000000000000" pitchFamily="2" charset="2"/>
+              <a:buChar char="Ø"/>
+            </a:pPr>
+            <a:r>
+              <a:rPr lang="en-US" sz="2000" dirty="0">
+                <a:latin typeface="Abadi" panose="020F0502020204030204" pitchFamily="34" charset="0"/>
+                <a:cs typeface="Arial" panose="020B0604020202020204" pitchFamily="34" charset="0"/>
+              </a:rPr>
+              <a:t> Lowering the chance of auditing</a:t>
+            </a:r>
+          </a:p>
+          <a:p>
+            <a:pPr>
+              <a:buFont typeface="Wingdings" panose="05000000000000000000" pitchFamily="2" charset="2"/>
+              <a:buChar char="Ø"/>
+            </a:pPr>
+            <a:r>
+              <a:rPr lang="en-US" sz="2000" dirty="0">
+                <a:latin typeface="Abadi" panose="020F0502020204030204" pitchFamily="34" charset="0"/>
+                <a:cs typeface="Arial" panose="020B0604020202020204" pitchFamily="34" charset="0"/>
+              </a:rPr>
+              <a:t> Digitally signing a document for authenticity</a:t>
+            </a:r>
+          </a:p>
+          <a:p>
+            <a:pPr>
+              <a:buFont typeface="Wingdings" panose="05000000000000000000" pitchFamily="2" charset="2"/>
+              <a:buChar char="Ø"/>
+            </a:pPr>
+            <a:r>
+              <a:rPr lang="en-US" sz="2000" dirty="0">
+                <a:latin typeface="Arial" panose="020B0604020202020204" pitchFamily="34" charset="0"/>
+                <a:cs typeface="Arial" panose="020B0604020202020204" pitchFamily="34" charset="0"/>
+              </a:rPr>
+              <a:t> As an additional layer of </a:t>
+            </a:r>
+            <a:r>
+              <a:rPr lang="en-US" sz="2000">
+                <a:latin typeface="Arial" panose="020B0604020202020204" pitchFamily="34" charset="0"/>
+                <a:cs typeface="Arial" panose="020B0604020202020204" pitchFamily="34" charset="0"/>
+              </a:rPr>
+              <a:t>security alongside </a:t>
+            </a:r>
+            <a:r>
+              <a:rPr lang="en-US" sz="2000" dirty="0">
+                <a:latin typeface="Arial" panose="020B0604020202020204" pitchFamily="34" charset="0"/>
+                <a:cs typeface="Arial" panose="020B0604020202020204" pitchFamily="34" charset="0"/>
+              </a:rPr>
+              <a:t>encryption</a:t>
+            </a:r>
+          </a:p>
+        </p:txBody>
+      </p:sp>
+    </p:spTree>
+    <p:extLst>
+      <p:ext uri="{BB962C8B-B14F-4D97-AF65-F5344CB8AC3E}">
+        <p14:creationId xmlns:p14="http://schemas.microsoft.com/office/powerpoint/2010/main" val="505410408"/>
       </p:ext>
     </p:extLst>
   </p:cSld>

</xml_diff>